<commit_message>
docs: update presentation decks with GitHub and Vercel links
</commit_message>
<xml_diff>
--- a/docs/presentation/SIGNOVA_AI_Presentation_12Slides.pptx
+++ b/docs/presentation/SIGNOVA_AI_Presentation_12Slides.pptx
@@ -6407,8 +6407,8 @@
         </p:nvSpPr>
         <p:spPr>
           <a:xfrm>
-            <a:off x="928116" y="1118711"/>
-            <a:ext cx="10332719" cy="5032057"/>
+            <a:off x="1112367" y="1051560"/>
+            <a:ext cx="9966960" cy="4855606"/>
           </a:xfrm>
           <a:prstGeom prst="rect">
             <a:avLst/>
@@ -6460,14 +6460,97 @@
         </p:blipFill>
         <p:spPr>
           <a:xfrm>
-            <a:off x="973836" y="1164431"/>
-            <a:ext cx="10241280" cy="4940617"/>
+            <a:off x="1158087" y="1097280"/>
+            <a:ext cx="9875520" cy="4764166"/>
           </a:xfrm>
           <a:prstGeom prst="rect">
             <a:avLst/>
           </a:prstGeom>
         </p:spPr>
       </p:pic>
+      <p:sp>
+        <p:nvSpPr>
+          <p:cNvPr id="5" name="Rounded Rectangle 4"/>
+          <p:cNvSpPr/>
+          <p:nvPr/>
+        </p:nvSpPr>
+        <p:spPr>
+          <a:xfrm>
+            <a:off x="1371600" y="5907024"/>
+            <a:ext cx="9448495" cy="347472"/>
+          </a:xfrm>
+          <a:prstGeom prst="roundRect">
+            <a:avLst/>
+          </a:prstGeom>
+          <a:solidFill>
+            <a:srgbClr val="FFFFFF"/>
+          </a:solidFill>
+          <a:ln w="15240">
+            <a:solidFill>
+              <a:srgbClr val="CBD5E1"/>
+            </a:solidFill>
+          </a:ln>
+        </p:spPr>
+        <p:style>
+          <a:lnRef idx="1">
+            <a:schemeClr val="accent1"/>
+          </a:lnRef>
+          <a:fillRef idx="3">
+            <a:schemeClr val="accent1"/>
+          </a:fillRef>
+          <a:effectRef idx="2">
+            <a:schemeClr val="accent1"/>
+          </a:effectRef>
+          <a:fontRef idx="minor">
+            <a:schemeClr val="lt1"/>
+          </a:fontRef>
+        </p:style>
+        <p:txBody>
+          <a:bodyPr rtlCol="0" anchor="ctr" wrap="square" lIns="0" rIns="0" tIns="0" bIns="0"/>
+          <a:lstStyle/>
+          <a:p>
+            <a:pPr algn="ctr"/>
+            <a:r>
+              <a:rPr sz="1100" b="1">
+                <a:solidFill>
+                  <a:srgbClr val="0A2540"/>
+                </a:solidFill>
+                <a:latin typeface="Segoe UI"/>
+              </a:rPr>
+              <a:t>Live App: </a:t>
+            </a:r>
+            <a:r>
+              <a:rPr sz="1100" b="1" u="sng">
+                <a:solidFill>
+                  <a:srgbClr val="0E7490"/>
+                </a:solidFill>
+                <a:latin typeface="Segoe UI"/>
+                <a:hlinkClick r:id="rId4"/>
+              </a:rPr>
+              <a:t>https://signova-ai-ashy.vercel.app</a:t>
+            </a:r>
+            <a:r>
+              <a:rPr sz="1100" b="1">
+                <a:solidFill>
+                  <a:srgbClr val="0A2540"/>
+                </a:solidFill>
+                <a:latin typeface="Segoe UI"/>
+              </a:rPr>
+              <a:t>   |   GitHub: </a:t>
+            </a:r>
+            <a:r>
+              <a:rPr sz="1100" b="1" u="sng">
+                <a:solidFill>
+                  <a:srgbClr val="0E7490"/>
+                </a:solidFill>
+                <a:latin typeface="Segoe UI"/>
+                <a:hlinkClick r:id="rId5"/>
+              </a:rPr>
+              <a:t>https://github.com/dhineshkumar-devx/signova-ai</a:t>
+            </a:r>
+          </a:p>
+        </p:txBody>
+      </p:sp>
     </p:spTree>
   </p:cSld>
   <p:clrMapOvr>

</xml_diff>